<commit_message>
Update RISCV-MCU documentation for clarity and accuracy
</commit_message>
<xml_diff>
--- a/Intro/RISCV-MCU.pptx
+++ b/Intro/RISCV-MCU.pptx
@@ -11094,8 +11094,8 @@
           </a:p>
         </p:txBody>
       </p:sp>
-      <mc:AlternateContent xmlns:mc="http://schemas.openxmlformats.org/markup-compatibility/2006">
-        <mc:Choice xmlns:a14="http://schemas.microsoft.com/office/drawing/2010/main" Requires="a14">
+      <mc:AlternateContent xmlns:mc="http://schemas.openxmlformats.org/markup-compatibility/2006" xmlns:a14="http://schemas.microsoft.com/office/drawing/2010/main">
+        <mc:Choice Requires="a14">
           <p:sp>
             <p:nvSpPr>
               <p:cNvPr id="20" name="文字方塊 19">
@@ -11185,7 +11185,7 @@
             </p:txBody>
           </p:sp>
         </mc:Choice>
-        <mc:Fallback>
+        <mc:Fallback xmlns="">
           <p:sp>
             <p:nvSpPr>
               <p:cNvPr id="20" name="文字方塊 19">
@@ -17884,7 +17884,7 @@
         </p:nvSpPr>
         <p:spPr>
           <a:xfrm>
-            <a:off x="7218004" y="2742561"/>
+            <a:off x="6096000" y="2725266"/>
             <a:ext cx="3492360" cy="811800"/>
           </a:xfrm>
           <a:prstGeom prst="roundRect">
@@ -18122,7 +18122,7 @@
         </p:nvCxnSpPr>
         <p:spPr>
           <a:xfrm flipV="1">
-            <a:off x="7473644" y="2460303"/>
+            <a:off x="6351640" y="2443008"/>
             <a:ext cx="0" cy="285835"/>
           </a:xfrm>
           <a:prstGeom prst="straightConnector1">
@@ -18146,7 +18146,7 @@
         </p:nvCxnSpPr>
         <p:spPr>
           <a:xfrm flipV="1">
-            <a:off x="8954875" y="2460303"/>
+            <a:off x="7832871" y="2443008"/>
             <a:ext cx="0" cy="282258"/>
           </a:xfrm>
           <a:prstGeom prst="straightConnector1">
@@ -18292,7 +18292,7 @@
         </p:nvSpPr>
         <p:spPr>
           <a:xfrm>
-            <a:off x="8801411" y="3660561"/>
+            <a:off x="7679407" y="3643266"/>
             <a:ext cx="249120" cy="479520"/>
           </a:xfrm>
           <a:prstGeom prst="downArrow">
@@ -18354,7 +18354,7 @@
         </p:nvSpPr>
         <p:spPr>
           <a:xfrm>
-            <a:off x="6781336" y="1557981"/>
+            <a:off x="5659332" y="1540686"/>
             <a:ext cx="1373040" cy="943560"/>
           </a:xfrm>
           <a:prstGeom prst="rect">
@@ -18908,7 +18908,30 @@
                 <a:latin typeface="Arial"/>
                 <a:ea typeface="Arial"/>
               </a:rPr>
-              <a:t>Data Mem</a:t>
+              <a:t>Data Mem /</a:t>
+            </a:r>
+            <a:endParaRPr lang="en-US" sz="1400" spc="-1" dirty="0">
+              <a:solidFill>
+                <a:schemeClr val="dk1"/>
+              </a:solidFill>
+              <a:latin typeface="Arial"/>
+              <a:ea typeface="Arial"/>
+            </a:endParaRPr>
+          </a:p>
+          <a:p>
+            <a:pPr algn="ctr">
+              <a:lnSpc>
+                <a:spcPct val="100000"/>
+              </a:lnSpc>
+            </a:pPr>
+            <a:r>
+              <a:rPr lang="en-US" sz="1400" b="0" strike="noStrike" spc="-1" dirty="0">
+                <a:solidFill>
+                  <a:schemeClr val="dk1"/>
+                </a:solidFill>
+                <a:latin typeface="Arial"/>
+              </a:rPr>
+              <a:t>Inst Mem /</a:t>
             </a:r>
             <a:endParaRPr lang="en-US" sz="1400" b="0" strike="noStrike" spc="-1" dirty="0">
               <a:solidFill>
@@ -18931,7 +18954,7 @@
                 <a:latin typeface="Arial"/>
                 <a:ea typeface="Arial"/>
               </a:rPr>
-              <a:t>128KB</a:t>
+              <a:t>Shared 128KB</a:t>
             </a:r>
             <a:endParaRPr lang="en-US" sz="1400" b="0" strike="noStrike" spc="-1" dirty="0">
               <a:solidFill>
@@ -18942,126 +18965,6 @@
           </a:p>
         </p:txBody>
       </p:sp>
-      <p:sp>
-        <p:nvSpPr>
-          <p:cNvPr id="92" name="矩形: 圓角 45"/>
-          <p:cNvSpPr/>
-          <p:nvPr/>
-        </p:nvSpPr>
-        <p:spPr>
-          <a:xfrm>
-            <a:off x="5013724" y="1622241"/>
-            <a:ext cx="1518840" cy="815040"/>
-          </a:xfrm>
-          <a:prstGeom prst="roundRect">
-            <a:avLst>
-              <a:gd name="adj" fmla="val 16667"/>
-            </a:avLst>
-          </a:prstGeom>
-          <a:solidFill>
-            <a:srgbClr val="FFC000"/>
-          </a:solidFill>
-          <a:ln>
-            <a:solidFill>
-              <a:srgbClr val="000000"/>
-            </a:solidFill>
-            <a:round/>
-          </a:ln>
-        </p:spPr>
-        <p:style>
-          <a:lnRef idx="2">
-            <a:schemeClr val="dk1">
-              <a:shade val="15000"/>
-            </a:schemeClr>
-          </a:lnRef>
-          <a:fillRef idx="1">
-            <a:schemeClr val="dk1"/>
-          </a:fillRef>
-          <a:effectRef idx="0">
-            <a:schemeClr val="dk1"/>
-          </a:effectRef>
-          <a:fontRef idx="minor"/>
-        </p:style>
-        <p:txBody>
-          <a:bodyPr lIns="90000" tIns="45000" rIns="90000" bIns="45000" anchor="ctr">
-            <a:noAutofit/>
-          </a:bodyPr>
-          <a:lstStyle/>
-          <a:p>
-            <a:pPr algn="ctr">
-              <a:lnSpc>
-                <a:spcPct val="100000"/>
-              </a:lnSpc>
-            </a:pPr>
-            <a:r>
-              <a:rPr lang="en-US" sz="1400" b="0" strike="noStrike" spc="-1">
-                <a:solidFill>
-                  <a:schemeClr val="dk1"/>
-                </a:solidFill>
-                <a:latin typeface="Arial"/>
-                <a:ea typeface="Arial"/>
-              </a:rPr>
-              <a:t>Inst MEM</a:t>
-            </a:r>
-            <a:endParaRPr lang="en-US" sz="1400" b="0" strike="noStrike" spc="-1">
-              <a:solidFill>
-                <a:srgbClr val="000000"/>
-              </a:solidFill>
-              <a:latin typeface="Arial"/>
-            </a:endParaRPr>
-          </a:p>
-          <a:p>
-            <a:pPr algn="ctr">
-              <a:lnSpc>
-                <a:spcPct val="100000"/>
-              </a:lnSpc>
-            </a:pPr>
-            <a:r>
-              <a:rPr lang="en-US" sz="1400" b="0" strike="noStrike" spc="-1">
-                <a:solidFill>
-                  <a:schemeClr val="dk1"/>
-                </a:solidFill>
-                <a:latin typeface="Arial"/>
-                <a:ea typeface="Arial"/>
-              </a:rPr>
-              <a:t>64KB</a:t>
-            </a:r>
-            <a:endParaRPr lang="en-US" sz="1400" b="0" strike="noStrike" spc="-1">
-              <a:solidFill>
-                <a:srgbClr val="000000"/>
-              </a:solidFill>
-              <a:latin typeface="Arial"/>
-            </a:endParaRPr>
-          </a:p>
-        </p:txBody>
-      </p:sp>
-      <p:cxnSp>
-        <p:nvCxnSpPr>
-          <p:cNvPr id="93" name="直線單箭頭接點 48"/>
-          <p:cNvCxnSpPr>
-            <a:stCxn id="92" idx="1"/>
-            <a:endCxn id="89" idx="3"/>
-          </p:cNvCxnSpPr>
-          <p:nvPr/>
-        </p:nvCxnSpPr>
-        <p:spPr>
-          <a:xfrm flipH="1">
-            <a:off x="4678564" y="2029761"/>
-            <a:ext cx="335520" cy="360"/>
-          </a:xfrm>
-          <a:prstGeom prst="straightConnector1">
-            <a:avLst/>
-          </a:prstGeom>
-          <a:ln w="28575">
-            <a:solidFill>
-              <a:srgbClr val="000000"/>
-            </a:solidFill>
-            <a:round/>
-            <a:headEnd type="arrow" w="med" len="med"/>
-            <a:tailEnd type="arrow" w="med" len="med"/>
-          </a:ln>
-        </p:spPr>
-      </p:cxnSp>
       <p:cxnSp>
         <p:nvCxnSpPr>
           <p:cNvPr id="94" name="直線單箭頭接點 51"/>
@@ -19103,7 +19006,7 @@
         </p:nvSpPr>
         <p:spPr>
           <a:xfrm>
-            <a:off x="7789374" y="1557633"/>
+            <a:off x="6667370" y="1540338"/>
             <a:ext cx="2331002" cy="1168097"/>
           </a:xfrm>
           <a:prstGeom prst="rect">
@@ -19251,7 +19154,7 @@
         </p:nvCxnSpPr>
         <p:spPr>
           <a:xfrm flipV="1">
-            <a:off x="10599357" y="2510286"/>
+            <a:off x="9477353" y="2492991"/>
             <a:ext cx="0" cy="231800"/>
           </a:xfrm>
           <a:prstGeom prst="straightConnector1">
@@ -19279,7 +19182,7 @@
         </p:nvSpPr>
         <p:spPr>
           <a:xfrm>
-            <a:off x="9912837" y="1557633"/>
+            <a:off x="8790833" y="1540338"/>
             <a:ext cx="1373040" cy="952653"/>
           </a:xfrm>
           <a:prstGeom prst="rect">

</xml_diff>